<commit_message>
Modified calibration to weigh uncertain options lesser, and changed Project_report and Project_slides
</commit_message>
<xml_diff>
--- a/Project_Slides.pptx
+++ b/Project_Slides.pptx
@@ -15,9 +15,10 @@
     <p:sldId id="263" r:id="rId9"/>
     <p:sldId id="264" r:id="rId10"/>
     <p:sldId id="265" r:id="rId11"/>
-    <p:sldId id="266" r:id="rId12"/>
-    <p:sldId id="267" r:id="rId13"/>
-    <p:sldId id="268" r:id="rId14"/>
+    <p:sldId id="269" r:id="rId12"/>
+    <p:sldId id="266" r:id="rId13"/>
+    <p:sldId id="267" r:id="rId14"/>
+    <p:sldId id="268" r:id="rId15"/>
   </p:sldIdLst>
   <p:sldSz cx="12192000" cy="6858000"/>
   <p:notesSz cx="6858000" cy="9144000"/>
@@ -116,6 +117,11 @@
       </a:defRPr>
     </a:lvl9pPr>
   </p:defaultTextStyle>
+  <p:extLst>
+    <p:ext uri="{EFAFB233-063F-42B5-8137-9DF3F51BA10A}">
+      <p15:sldGuideLst xmlns:p15="http://schemas.microsoft.com/office/powerpoint/2012/main"/>
+    </p:ext>
+  </p:extLst>
 </p:presentation>
 </file>
 
@@ -841,7 +847,7 @@
           <a:p>
             <a:fld id="{FC36C9A5-BCC8-42D4-B3CC-BDB3B2111420}" type="datetimeFigureOut">
               <a:rPr lang="en-US" smtClean="0"/>
-              <a:t>3/20/2026</a:t>
+              <a:t>5/1/2026</a:t>
             </a:fld>
             <a:endParaRPr lang="en-US"/>
           </a:p>
@@ -1092,7 +1098,7 @@
           <a:p>
             <a:fld id="{FC36C9A5-BCC8-42D4-B3CC-BDB3B2111420}" type="datetimeFigureOut">
               <a:rPr lang="en-US" smtClean="0"/>
-              <a:t>3/20/2026</a:t>
+              <a:t>5/1/2026</a:t>
             </a:fld>
             <a:endParaRPr lang="en-US"/>
           </a:p>
@@ -1406,7 +1412,7 @@
           <a:p>
             <a:fld id="{FC36C9A5-BCC8-42D4-B3CC-BDB3B2111420}" type="datetimeFigureOut">
               <a:rPr lang="en-US" smtClean="0"/>
-              <a:t>3/20/2026</a:t>
+              <a:t>5/1/2026</a:t>
             </a:fld>
             <a:endParaRPr lang="en-US"/>
           </a:p>
@@ -1747,7 +1753,7 @@
           <a:p>
             <a:fld id="{FC36C9A5-BCC8-42D4-B3CC-BDB3B2111420}" type="datetimeFigureOut">
               <a:rPr lang="en-US" smtClean="0"/>
-              <a:t>3/20/2026</a:t>
+              <a:t>5/1/2026</a:t>
             </a:fld>
             <a:endParaRPr lang="en-US"/>
           </a:p>
@@ -2061,7 +2067,7 @@
           <a:p>
             <a:fld id="{FC36C9A5-BCC8-42D4-B3CC-BDB3B2111420}" type="datetimeFigureOut">
               <a:rPr lang="en-US" smtClean="0"/>
-              <a:t>3/20/2026</a:t>
+              <a:t>5/1/2026</a:t>
             </a:fld>
             <a:endParaRPr lang="en-US"/>
           </a:p>
@@ -2454,7 +2460,7 @@
           <a:p>
             <a:fld id="{FC36C9A5-BCC8-42D4-B3CC-BDB3B2111420}" type="datetimeFigureOut">
               <a:rPr lang="en-US" smtClean="0"/>
-              <a:t>3/20/2026</a:t>
+              <a:t>5/1/2026</a:t>
             </a:fld>
             <a:endParaRPr lang="en-US"/>
           </a:p>
@@ -2624,7 +2630,7 @@
           <a:p>
             <a:fld id="{FC36C9A5-BCC8-42D4-B3CC-BDB3B2111420}" type="datetimeFigureOut">
               <a:rPr lang="en-US" smtClean="0"/>
-              <a:t>3/20/2026</a:t>
+              <a:t>5/1/2026</a:t>
             </a:fld>
             <a:endParaRPr lang="en-US"/>
           </a:p>
@@ -2804,7 +2810,7 @@
           <a:p>
             <a:fld id="{FC36C9A5-BCC8-42D4-B3CC-BDB3B2111420}" type="datetimeFigureOut">
               <a:rPr lang="en-US" smtClean="0"/>
-              <a:t>3/20/2026</a:t>
+              <a:t>5/1/2026</a:t>
             </a:fld>
             <a:endParaRPr lang="en-US"/>
           </a:p>
@@ -2980,7 +2986,7 @@
           <a:p>
             <a:fld id="{FC36C9A5-BCC8-42D4-B3CC-BDB3B2111420}" type="datetimeFigureOut">
               <a:rPr lang="en-US" smtClean="0"/>
-              <a:t>3/20/2026</a:t>
+              <a:t>5/1/2026</a:t>
             </a:fld>
             <a:endParaRPr lang="en-US"/>
           </a:p>
@@ -3227,7 +3233,7 @@
           <a:p>
             <a:fld id="{FC36C9A5-BCC8-42D4-B3CC-BDB3B2111420}" type="datetimeFigureOut">
               <a:rPr lang="en-US" smtClean="0"/>
-              <a:t>3/20/2026</a:t>
+              <a:t>5/1/2026</a:t>
             </a:fld>
             <a:endParaRPr lang="en-US"/>
           </a:p>
@@ -3459,7 +3465,7 @@
           <a:p>
             <a:fld id="{FC36C9A5-BCC8-42D4-B3CC-BDB3B2111420}" type="datetimeFigureOut">
               <a:rPr lang="en-US" smtClean="0"/>
-              <a:t>3/20/2026</a:t>
+              <a:t>5/1/2026</a:t>
             </a:fld>
             <a:endParaRPr lang="en-US"/>
           </a:p>
@@ -3833,7 +3839,7 @@
           <a:p>
             <a:fld id="{FC36C9A5-BCC8-42D4-B3CC-BDB3B2111420}" type="datetimeFigureOut">
               <a:rPr lang="en-US" smtClean="0"/>
-              <a:t>3/20/2026</a:t>
+              <a:t>5/1/2026</a:t>
             </a:fld>
             <a:endParaRPr lang="en-US"/>
           </a:p>
@@ -3956,7 +3962,7 @@
           <a:p>
             <a:fld id="{FC36C9A5-BCC8-42D4-B3CC-BDB3B2111420}" type="datetimeFigureOut">
               <a:rPr lang="en-US" smtClean="0"/>
-              <a:t>3/20/2026</a:t>
+              <a:t>5/1/2026</a:t>
             </a:fld>
             <a:endParaRPr lang="en-US"/>
           </a:p>
@@ -4051,7 +4057,7 @@
           <a:p>
             <a:fld id="{FC36C9A5-BCC8-42D4-B3CC-BDB3B2111420}" type="datetimeFigureOut">
               <a:rPr lang="en-US" smtClean="0"/>
-              <a:t>3/20/2026</a:t>
+              <a:t>5/1/2026</a:t>
             </a:fld>
             <a:endParaRPr lang="en-US"/>
           </a:p>
@@ -4306,7 +4312,7 @@
           <a:p>
             <a:fld id="{FC36C9A5-BCC8-42D4-B3CC-BDB3B2111420}" type="datetimeFigureOut">
               <a:rPr lang="en-US" smtClean="0"/>
-              <a:t>3/20/2026</a:t>
+              <a:t>5/1/2026</a:t>
             </a:fld>
             <a:endParaRPr lang="en-US"/>
           </a:p>
@@ -4569,7 +4575,7 @@
           <a:p>
             <a:fld id="{FC36C9A5-BCC8-42D4-B3CC-BDB3B2111420}" type="datetimeFigureOut">
               <a:rPr lang="en-US" smtClean="0"/>
-              <a:t>3/20/2026</a:t>
+              <a:t>5/1/2026</a:t>
             </a:fld>
             <a:endParaRPr lang="en-US"/>
           </a:p>
@@ -5312,7 +5318,7 @@
           <a:p>
             <a:fld id="{FC36C9A5-BCC8-42D4-B3CC-BDB3B2111420}" type="datetimeFigureOut">
               <a:rPr lang="en-US" smtClean="0"/>
-              <a:t>3/20/2026</a:t>
+              <a:t>5/1/2026</a:t>
             </a:fld>
             <a:endParaRPr lang="en-US"/>
           </a:p>
@@ -6028,6 +6034,130 @@
           <p:cNvPr id="2" name="Title 1">
             <a:extLst>
               <a:ext uri="{FF2B5EF4-FFF2-40B4-BE49-F238E27FC236}">
+                <a16:creationId xmlns:a16="http://schemas.microsoft.com/office/drawing/2014/main" id="{302C9D89-2CC2-EC47-DCC2-D91605CE2ABF}"/>
+              </a:ext>
+            </a:extLst>
+          </p:cNvPr>
+          <p:cNvSpPr>
+            <a:spLocks noGrp="1"/>
+          </p:cNvSpPr>
+          <p:nvPr>
+            <p:ph type="title"/>
+          </p:nvPr>
+        </p:nvSpPr>
+        <p:spPr/>
+        <p:txBody>
+          <a:bodyPr/>
+          <a:lstStyle/>
+          <a:p>
+            <a:r>
+              <a:rPr lang="en-US" dirty="0"/>
+              <a:t>Calibration</a:t>
+            </a:r>
+          </a:p>
+        </p:txBody>
+      </p:sp>
+      <p:sp>
+        <p:nvSpPr>
+          <p:cNvPr id="3" name="Content Placeholder 2">
+            <a:extLst>
+              <a:ext uri="{FF2B5EF4-FFF2-40B4-BE49-F238E27FC236}">
+                <a16:creationId xmlns:a16="http://schemas.microsoft.com/office/drawing/2014/main" id="{97DECD37-DFE1-56E7-61CA-A7A07E916216}"/>
+              </a:ext>
+            </a:extLst>
+          </p:cNvPr>
+          <p:cNvSpPr>
+            <a:spLocks noGrp="1"/>
+          </p:cNvSpPr>
+          <p:nvPr>
+            <p:ph idx="1"/>
+          </p:nvPr>
+        </p:nvSpPr>
+        <p:spPr/>
+        <p:txBody>
+          <a:bodyPr/>
+          <a:lstStyle/>
+          <a:p>
+            <a:r>
+              <a:rPr lang="en-US" b="1" dirty="0"/>
+              <a:t>Market data acquisition</a:t>
+            </a:r>
+            <a:r>
+              <a:rPr lang="en-US" dirty="0"/>
+              <a:t> — Live option chain data for the target stock is retrieved via the </a:t>
+            </a:r>
+            <a:r>
+              <a:rPr lang="en-US" dirty="0" err="1"/>
+              <a:t>yfinance</a:t>
+            </a:r>
+            <a:r>
+              <a:rPr lang="en-US" dirty="0"/>
+              <a:t> library, covering a range of strikes and maturities.</a:t>
+            </a:r>
+          </a:p>
+          <a:p>
+            <a:endParaRPr lang="en-US" dirty="0"/>
+          </a:p>
+          <a:p>
+            <a:r>
+              <a:rPr lang="en-US" b="1" dirty="0"/>
+              <a:t>Data cleaning</a:t>
+            </a:r>
+            <a:r>
+              <a:rPr lang="en-US" dirty="0"/>
+              <a:t> — Illiquid contracts are filtered out to ensure calibration is not distorted by unreliable quotes.</a:t>
+            </a:r>
+          </a:p>
+          <a:p>
+            <a:endParaRPr lang="en-US" dirty="0"/>
+          </a:p>
+          <a:p>
+            <a:r>
+              <a:rPr lang="en-US" b="1" dirty="0"/>
+              <a:t>Parameter calibration</a:t>
+            </a:r>
+            <a:r>
+              <a:rPr lang="en-US" dirty="0"/>
+              <a:t> — The Kou model parameters are recovered by minimizing the distance between model-implied and market-implied volatilities, fitting the observed volatility smile. For this, we use the L-BFGS-B method. </a:t>
+            </a:r>
+          </a:p>
+        </p:txBody>
+      </p:sp>
+    </p:spTree>
+    <p:extLst>
+      <p:ext uri="{BB962C8B-B14F-4D97-AF65-F5344CB8AC3E}">
+        <p14:creationId xmlns:p14="http://schemas.microsoft.com/office/powerpoint/2010/main" val="2812303108"/>
+      </p:ext>
+    </p:extLst>
+  </p:cSld>
+  <p:clrMapOvr>
+    <a:masterClrMapping/>
+  </p:clrMapOvr>
+</p:sld>
+</file>
+
+<file path=ppt/slides/slide12.xml><?xml version="1.0" encoding="utf-8"?>
+<p:sld xmlns:a="http://schemas.openxmlformats.org/drawingml/2006/main" xmlns:r="http://schemas.openxmlformats.org/officeDocument/2006/relationships" xmlns:p="http://schemas.openxmlformats.org/presentationml/2006/main">
+  <p:cSld>
+    <p:spTree>
+      <p:nvGrpSpPr>
+        <p:cNvPr id="1" name=""/>
+        <p:cNvGrpSpPr/>
+        <p:nvPr/>
+      </p:nvGrpSpPr>
+      <p:grpSpPr>
+        <a:xfrm>
+          <a:off x="0" y="0"/>
+          <a:ext cx="0" cy="0"/>
+          <a:chOff x="0" y="0"/>
+          <a:chExt cx="0" cy="0"/>
+        </a:xfrm>
+      </p:grpSpPr>
+      <p:sp>
+        <p:nvSpPr>
+          <p:cNvPr id="2" name="Title 1">
+            <a:extLst>
+              <a:ext uri="{FF2B5EF4-FFF2-40B4-BE49-F238E27FC236}">
                 <a16:creationId xmlns:a16="http://schemas.microsoft.com/office/drawing/2014/main" id="{C6AFB6FE-FDB6-2D8A-5200-DF222A579F2E}"/>
               </a:ext>
             </a:extLst>
@@ -6101,7 +6231,7 @@
 </p:sld>
 </file>
 
-<file path=ppt/slides/slide12.xml><?xml version="1.0" encoding="utf-8"?>
+<file path=ppt/slides/slide13.xml><?xml version="1.0" encoding="utf-8"?>
 <p:sld xmlns:a="http://schemas.openxmlformats.org/drawingml/2006/main" xmlns:r="http://schemas.openxmlformats.org/officeDocument/2006/relationships" xmlns:p="http://schemas.openxmlformats.org/presentationml/2006/main">
   <p:cSld>
     <p:spTree>
@@ -6200,7 +6330,7 @@
 </p:sld>
 </file>
 
-<file path=ppt/slides/slide13.xml><?xml version="1.0" encoding="utf-8"?>
+<file path=ppt/slides/slide14.xml><?xml version="1.0" encoding="utf-8"?>
 <p:sld xmlns:a="http://schemas.openxmlformats.org/drawingml/2006/main" xmlns:r="http://schemas.openxmlformats.org/officeDocument/2006/relationships" xmlns:p="http://schemas.openxmlformats.org/presentationml/2006/main">
   <p:cSld>
     <p:spTree>
@@ -6371,7 +6501,7 @@
           <a:p>
             <a:r>
               <a:rPr lang="en-US" dirty="0"/>
-              <a:t>This project implements a pricing and hedging framework based on the Kou Model.</a:t>
+              <a:t>This project implements a pricing, calibration and hedging framework based on the Kou Model.</a:t>
             </a:r>
           </a:p>
           <a:p>
@@ -6383,7 +6513,7 @@
           <a:p>
             <a:r>
               <a:rPr lang="en-US" dirty="0"/>
-              <a:t>The goal is to assess whether the idea of “Delta-Hedging” works in the context of the Kou Model. </a:t>
+              <a:t>One of the goals is to assess whether the idea of “Delta-Hedging” works in the context of the Kou Model. </a:t>
             </a:r>
           </a:p>
           <a:p>
@@ -6955,8 +7085,8 @@
           </a:p>
         </p:txBody>
       </p:sp>
-      <mc:AlternateContent xmlns:mc="http://schemas.openxmlformats.org/markup-compatibility/2006">
-        <mc:Choice xmlns:a14="http://schemas.microsoft.com/office/drawing/2010/main" Requires="a14">
+      <mc:AlternateContent xmlns:mc="http://schemas.openxmlformats.org/markup-compatibility/2006" xmlns:a14="http://schemas.microsoft.com/office/drawing/2010/main">
+        <mc:Choice Requires="a14">
           <p:sp>
             <p:nvSpPr>
               <p:cNvPr id="3" name="Content Placeholder 2">
@@ -7063,7 +7193,7 @@
             </p:txBody>
           </p:sp>
         </mc:Choice>
-        <mc:Fallback>
+        <mc:Fallback xmlns="">
           <p:sp>
             <p:nvSpPr>
               <p:cNvPr id="3" name="Content Placeholder 2">
@@ -8403,8 +8533,8 @@
           </a:p>
         </p:txBody>
       </p:sp>
-      <mc:AlternateContent xmlns:mc="http://schemas.openxmlformats.org/markup-compatibility/2006">
-        <mc:Choice xmlns:a14="http://schemas.microsoft.com/office/drawing/2010/main" Requires="a14">
+      <mc:AlternateContent xmlns:mc="http://schemas.openxmlformats.org/markup-compatibility/2006" xmlns:a14="http://schemas.microsoft.com/office/drawing/2010/main">
+        <mc:Choice Requires="a14">
           <p:sp>
             <p:nvSpPr>
               <p:cNvPr id="3" name="Content Placeholder 2">
@@ -8597,7 +8727,7 @@
             </p:txBody>
           </p:sp>
         </mc:Choice>
-        <mc:Fallback>
+        <mc:Fallback xmlns="">
           <p:sp>
             <p:nvSpPr>
               <p:cNvPr id="3" name="Content Placeholder 2">

</xml_diff>